<commit_message>
fix review findings M17-M20 and sync documentation with code
- METHOD_NOT_ALLOWED for 405; INTEGRATION_UNAVAILABLE documented as sync_run only
- admin audit: pages, newest first, filters by person, object and period;
  setting changes record their key
- CRM inbox mock rejects garbage documents instead of answering 500
- docs PDF builder keeps <...> inside code, splits tables only on unescaped |,
  fails on missing sources and is reproducible (date of the last source commit)
- presentation builder: repo root from the script path, pinned pptxgenjs with
  package-lock, API and test counts read from the contract and tests
- ARCHITECTURE: FK delete convention, data model fields, ADR-008 scope, ADR-018,
  ADR-022, ADR-023 retention, error catalog, methods table; COMPLIANCE, SECURITY,
  DATA_PROCESSING, ADMIN_GUIDE, DEPLOY, frontend screens spec, review sections

Co-Authored-By: Claude Opus 5.5 <noreply@anthropic.com>
</commit_message>
<xml_diff>
--- a/docs/РадарВузов-презентация.pptx
+++ b/docs/РадарВузов-презентация.pptx
@@ -2004,7 +2004,7 @@
                 <a:ea typeface="Calibri" pitchFamily="34" charset="-122"/>
                 <a:cs typeface="Calibri" pitchFamily="34" charset="-120"/>
               </a:rPr>
-              <a:t>Работающий прототип: 100 методов API, 319 тестов, демо-стенд на 351 записи</a:t>
+              <a:t>Работающий прототип: 116 операций API, 332 теста, демо-стенд на 351 записи</a:t>
             </a:r>
             <a:endParaRPr lang="en-US" sz="1300" dirty="0"/>
           </a:p>
@@ -3816,7 +3816,7 @@
                 <a:ea typeface="Calibri" pitchFamily="34" charset="-122"/>
                 <a:cs typeface="Calibri" pitchFamily="34" charset="-120"/>
               </a:rPr>
-              <a:t>100 методов API и контракт, 319 тестов, 46 таблиц</a:t>
+              <a:t>116 операций на 102 путях API, контракт, 332 теста, 46 таблиц</a:t>
             </a:r>
             <a:endParaRPr lang="en-US" sz="1400" dirty="0"/>
           </a:p>

</xml_diff>

<commit_message>
docs: presentation counts tests via pytest, rebuilt deck and documentation PDF
Co-Authored-By: Claude Opus 5.5 <noreply@anthropic.com>
</commit_message>
<xml_diff>
--- a/docs/РадарВузов-презентация.pptx
+++ b/docs/РадарВузов-презентация.pptx
@@ -2004,7 +2004,7 @@
                 <a:ea typeface="Calibri" pitchFamily="34" charset="-122"/>
                 <a:cs typeface="Calibri" pitchFamily="34" charset="-120"/>
               </a:rPr>
-              <a:t>Работающий прототип: 116 операций API, 332 теста, демо-стенд на 351 записи</a:t>
+              <a:t>Работающий прототип: 116 операций API, 379 тестов, демо-стенд на 351 записи</a:t>
             </a:r>
             <a:endParaRPr lang="en-US" sz="1300" dirty="0"/>
           </a:p>
@@ -3816,7 +3816,7 @@
                 <a:ea typeface="Calibri" pitchFamily="34" charset="-122"/>
                 <a:cs typeface="Calibri" pitchFamily="34" charset="-120"/>
               </a:rPr>
-              <a:t>116 операций на 102 путях API, контракт, 332 теста, 46 таблиц</a:t>
+              <a:t>116 операций на 102 путях API, контракт, 379 тестов, 46 таблиц</a:t>
             </a:r>
             <a:endParaRPr lang="en-US" sz="1400" dirty="0"/>
           </a:p>

</xml_diff>

<commit_message>
docs: S3 storage explained honestly — Object Storage on the Yandex stand, MinIO locally
- ARCHITECTURE, SECURITY, ADMIN_GUIDE, DEMO_SCRIPT, JURY_QA, Archi model: files live in
  S3-compatible storage; on the stand it is a versioned Yandex Object Storage bucket,
  in a closed perimeter and in local compose it is MinIO; same code, different address
- deployment diagram redrawn for the Yandex Cloud stand; both diagram images re-rendered
- the stand is deployed: COMPLIANCE SUB-03 and DEPLOY state point to
  https://93-77-190-189.sslip.io with the smoke results
- presentation slide and PDFs rebuilt

Co-Authored-By: Claude Opus 5.5 <noreply@anthropic.com>
</commit_message>
<xml_diff>
--- a/docs/РадарВузов-презентация.pptx
+++ b/docs/РадарВузов-презентация.pptx
@@ -8236,7 +8236,7 @@
                 <a:ea typeface="Calibri" pitchFamily="34" charset="-122"/>
                 <a:cs typeface="Calibri" pitchFamily="34" charset="-120"/>
               </a:rPr>
-              <a:t>Один сервер, docker compose, наружу только 80 и 443</a:t>
+              <a:t>Сервер в Yandex Cloud, docker compose, файлы в Object Storage; наружу только 80 и 443</a:t>
             </a:r>
             <a:endParaRPr lang="en-US" sz="1400" dirty="0"/>
           </a:p>
@@ -8794,7 +8794,7 @@
                 <a:ea typeface="Calibri" pitchFamily="34" charset="-122"/>
                 <a:cs typeface="Calibri" pitchFamily="34" charset="-120"/>
               </a:rPr>
-              <a:t>MinIO (S3)</a:t>
+              <a:t>S3: Object Storage / MinIO</a:t>
             </a:r>
             <a:endParaRPr lang="en-US" sz="1300" dirty="0"/>
           </a:p>
@@ -8867,7 +8867,7 @@
                 <a:ea typeface="Calibri" pitchFamily="34" charset="-122"/>
                 <a:cs typeface="Calibri" pitchFamily="34" charset="-120"/>
               </a:rPr>
-              <a:t>Резервные копии раз в сутки: дамп базы и зеркало файлов из MinIO — в один том, с проверкой восстановления</a:t>
+              <a:t>Копии раз в сутки: дамп базы с проверкой восстановления; файлы — в S3 с версионированием, копии шифруются во внешний бакет</a:t>
             </a:r>
             <a:endParaRPr lang="en-US" sz="1300" dirty="0"/>
           </a:p>

</xml_diff>